<commit_message>
docs: final submission deck with Kakwe screens, Cloud Run hosting and web.app APK
Replaces every screenshot that showed the old name with Kakwe captures from
feat/production, uses the approved Home and Check v3 mockups on the
wireframe slide, states the API runs on Cloud Run in asia-southeast1, links
the APK on web.app and drops the done Cloud Run and Check redesign items
from the roadmap and the tunnel limit.
</commit_message>
<xml_diff>
--- a/pitch/Kakwe-AIBuilderCup-submission.pptx
+++ b/pitch/Kakwe-AIBuilderCup-submission.pptx
@@ -7884,7 +7884,7 @@
       </p:sp>
       <p:pic>
         <p:nvPicPr>
-          <p:cNvPr id="136" name="Picture 135" descr="ph-danger-en.png"/>
+          <p:cNvPr id="136" name="Picture 135" descr="ph-check.png"/>
           <p:cNvPicPr>
             <a:picLocks noChangeAspect="1"/>
           </p:cNvPicPr>
@@ -7915,6 +7915,70 @@
         <p:spPr>
           <a:xfrm>
             <a:off x="201168" y="4151376"/>
+            <a:ext cx="1766316" cy="384048"/>
+          </a:xfrm>
+          <a:prstGeom prst="rect">
+            <a:avLst/>
+          </a:prstGeom>
+          <a:noFill/>
+        </p:spPr>
+        <p:txBody>
+          <a:bodyPr wrap="square" anchor="t" lIns="0" rIns="0" tIns="0" bIns="0"/>
+          <a:lstStyle/>
+          <a:p>
+            <a:pPr algn="ctr">
+              <a:lnSpc>
+                <a:spcPct val="110000"/>
+              </a:lnSpc>
+            </a:pPr>
+            <a:r>
+              <a:rPr sz="1000" b="1">
+                <a:solidFill>
+                  <a:srgbClr val="1F1A17"/>
+                </a:solidFill>
+                <a:latin typeface="Google Sans Flex"/>
+                <a:ea typeface="Google Sans Flex"/>
+                <a:cs typeface="Google Sans Flex"/>
+                <a:sym typeface="Google Sans Flex"/>
+              </a:rPr>
+              <a:t>Check: pick what to check</a:t>
+            </a:r>
+          </a:p>
+        </p:txBody>
+      </p:sp>
+      <p:pic>
+        <p:nvPicPr>
+          <p:cNvPr id="138" name="Picture 137" descr="ph-danger-en.png"/>
+          <p:cNvPicPr>
+            <a:picLocks noChangeAspect="1"/>
+          </p:cNvPicPr>
+          <p:nvPr/>
+        </p:nvPicPr>
+        <p:blipFill>
+          <a:blip r:embed="rId6"/>
+          <a:stretch>
+            <a:fillRect/>
+          </a:stretch>
+        </p:blipFill>
+        <p:spPr>
+          <a:xfrm>
+            <a:off x="2082164" y="1078992"/>
+            <a:ext cx="1491996" cy="3017520"/>
+          </a:xfrm>
+          <a:prstGeom prst="rect">
+            <a:avLst/>
+          </a:prstGeom>
+        </p:spPr>
+      </p:pic>
+      <p:sp>
+        <p:nvSpPr>
+          <p:cNvPr id="139" name="TextBox 138"/>
+          <p:cNvSpPr txBox="1"/>
+          <p:nvPr/>
+        </p:nvSpPr>
+        <p:spPr>
+          <a:xfrm>
+            <a:off x="1945005" y="4151376"/>
             <a:ext cx="1766316" cy="384048"/>
           </a:xfrm>
           <a:prstGeom prst="rect">
@@ -7948,21 +8012,21 @@
       </p:sp>
       <p:pic>
         <p:nvPicPr>
-          <p:cNvPr id="138" name="Picture 137" descr="ph-jobshield.png"/>
+          <p:cNvPr id="140" name="Picture 139" descr="ph-jobshield.png"/>
           <p:cNvPicPr>
             <a:picLocks noChangeAspect="1"/>
           </p:cNvPicPr>
           <p:nvPr/>
         </p:nvPicPr>
         <p:blipFill>
-          <a:blip r:embed="rId6"/>
+          <a:blip r:embed="rId7"/>
           <a:stretch>
             <a:fillRect/>
           </a:stretch>
         </p:blipFill>
         <p:spPr>
           <a:xfrm>
-            <a:off x="2082164" y="1078992"/>
+            <a:off x="3826001" y="1078992"/>
             <a:ext cx="1491996" cy="3017520"/>
           </a:xfrm>
           <a:prstGeom prst="rect">
@@ -7972,13 +8036,13 @@
       </p:pic>
       <p:sp>
         <p:nvSpPr>
-          <p:cNvPr id="139" name="TextBox 138"/>
+          <p:cNvPr id="141" name="TextBox 140"/>
           <p:cNvSpPr txBox="1"/>
           <p:nvPr/>
         </p:nvSpPr>
         <p:spPr>
           <a:xfrm>
-            <a:off x="1945005" y="4151376"/>
+            <a:off x="3688841" y="4151376"/>
             <a:ext cx="1766316" cy="384048"/>
           </a:xfrm>
           <a:prstGeom prst="rect">
@@ -8012,21 +8076,21 @@
       </p:sp>
       <p:pic>
         <p:nvPicPr>
-          <p:cNvPr id="140" name="Picture 139" descr="ph-bubble.png"/>
+          <p:cNvPr id="142" name="Picture 141" descr="ph-bubble.png"/>
           <p:cNvPicPr>
             <a:picLocks noChangeAspect="1"/>
           </p:cNvPicPr>
           <p:nvPr/>
         </p:nvPicPr>
         <p:blipFill>
-          <a:blip r:embed="rId7"/>
+          <a:blip r:embed="rId8"/>
           <a:stretch>
             <a:fillRect/>
           </a:stretch>
         </p:blipFill>
         <p:spPr>
           <a:xfrm>
-            <a:off x="3826001" y="1078992"/>
+            <a:off x="5569839" y="1078992"/>
             <a:ext cx="1491996" cy="3017520"/>
           </a:xfrm>
           <a:prstGeom prst="rect">
@@ -8036,13 +8100,13 @@
       </p:pic>
       <p:sp>
         <p:nvSpPr>
-          <p:cNvPr id="141" name="TextBox 140"/>
+          <p:cNvPr id="143" name="TextBox 142"/>
           <p:cNvSpPr txBox="1"/>
           <p:nvPr/>
         </p:nvSpPr>
         <p:spPr>
           <a:xfrm>
-            <a:off x="3688841" y="4151376"/>
+            <a:off x="5432678" y="4151376"/>
             <a:ext cx="1766316" cy="384048"/>
           </a:xfrm>
           <a:prstGeom prst="rect">
@@ -8076,21 +8140,21 @@
       </p:sp>
       <p:pic>
         <p:nvPicPr>
-          <p:cNvPr id="142" name="Picture 141" descr="ph-danger-my.png"/>
+          <p:cNvPr id="144" name="Picture 143" descr="ph-report-my.png"/>
           <p:cNvPicPr>
             <a:picLocks noChangeAspect="1"/>
           </p:cNvPicPr>
           <p:nvPr/>
         </p:nvPicPr>
         <p:blipFill>
-          <a:blip r:embed="rId8"/>
+          <a:blip r:embed="rId9"/>
           <a:stretch>
             <a:fillRect/>
           </a:stretch>
         </p:blipFill>
         <p:spPr>
           <a:xfrm>
-            <a:off x="5569839" y="1078992"/>
+            <a:off x="7313676" y="1078992"/>
             <a:ext cx="1491996" cy="3017520"/>
           </a:xfrm>
           <a:prstGeom prst="rect">
@@ -8100,13 +8164,13 @@
       </p:pic>
       <p:sp>
         <p:nvSpPr>
-          <p:cNvPr id="143" name="TextBox 142"/>
+          <p:cNvPr id="145" name="TextBox 144"/>
           <p:cNvSpPr txBox="1"/>
           <p:nvPr/>
         </p:nvSpPr>
         <p:spPr>
           <a:xfrm>
-            <a:off x="5432678" y="4151376"/>
+            <a:off x="7176515" y="4151376"/>
             <a:ext cx="1766316" cy="384048"/>
           </a:xfrm>
           <a:prstGeom prst="rect">
@@ -8133,71 +8197,7 @@
                 <a:cs typeface="Google Sans Flex"/>
                 <a:sym typeface="Google Sans Flex"/>
               </a:rPr>
-              <a:t>Burmese report, voice button</a:t>
-            </a:r>
-          </a:p>
-        </p:txBody>
-      </p:sp>
-      <p:pic>
-        <p:nvPicPr>
-          <p:cNvPr id="144" name="Picture 143" descr="ph-warn.png"/>
-          <p:cNvPicPr>
-            <a:picLocks noChangeAspect="1"/>
-          </p:cNvPicPr>
-          <p:nvPr/>
-        </p:nvPicPr>
-        <p:blipFill>
-          <a:blip r:embed="rId9"/>
-          <a:stretch>
-            <a:fillRect/>
-          </a:stretch>
-        </p:blipFill>
-        <p:spPr>
-          <a:xfrm>
-            <a:off x="7313676" y="1078992"/>
-            <a:ext cx="1491996" cy="3017520"/>
-          </a:xfrm>
-          <a:prstGeom prst="rect">
-            <a:avLst/>
-          </a:prstGeom>
-        </p:spPr>
-      </p:pic>
-      <p:sp>
-        <p:nvSpPr>
-          <p:cNvPr id="145" name="TextBox 144"/>
-          <p:cNvSpPr txBox="1"/>
-          <p:nvPr/>
-        </p:nvSpPr>
-        <p:spPr>
-          <a:xfrm>
-            <a:off x="7176515" y="4151376"/>
-            <a:ext cx="1766316" cy="384048"/>
-          </a:xfrm>
-          <a:prstGeom prst="rect">
-            <a:avLst/>
-          </a:prstGeom>
-          <a:noFill/>
-        </p:spPr>
-        <p:txBody>
-          <a:bodyPr wrap="square" anchor="t" lIns="0" rIns="0" tIns="0" bIns="0"/>
-          <a:lstStyle/>
-          <a:p>
-            <a:pPr algn="ctr">
-              <a:lnSpc>
-                <a:spcPct val="110000"/>
-              </a:lnSpc>
-            </a:pPr>
-            <a:r>
-              <a:rPr sz="1000" b="1">
-                <a:solidFill>
-                  <a:srgbClr val="1F1A17"/>
-                </a:solidFill>
-                <a:latin typeface="Google Sans Flex"/>
-                <a:ea typeface="Google Sans Flex"/>
-                <a:cs typeface="Google Sans Flex"/>
-                <a:sym typeface="Google Sans Flex"/>
-              </a:rPr>
-              <a:t>Warn my family</a:t>
+              <a:t>Burmese report, voice and family</a:t>
             </a:r>
           </a:p>
         </p:txBody>
@@ -8237,7 +8237,7 @@
                 <a:cs typeface="Google Sans Flex"/>
                 <a:sym typeface="Google Sans Flex"/>
               </a:rPr>
-              <a:t>Web build captures with fictional inputs. Job Shield uses built-in demo data. The bubble shows Android overlay views on a drawn chat.</a:t>
+              <a:t>Web build captures with fictional inputs and the built-in demo data. The bubble shows the Android overlay views on a drawn chat.</a:t>
             </a:r>
           </a:p>
         </p:txBody>
@@ -9641,7 +9641,7 @@
                 <a:cs typeface="Google Sans Flex"/>
                 <a:sym typeface="Google Sans Flex"/>
               </a:rPr>
-              <a:t>Move the API to Cloud Run</a:t>
+              <a:t>Human review of the real-screenshot labels</a:t>
             </a:r>
           </a:p>
         </p:txBody>
@@ -9781,7 +9781,7 @@
                 <a:cs typeface="Google Sans Flex"/>
                 <a:sym typeface="Google Sans Flex"/>
               </a:rPr>
-              <a:t>A simpler Check page and a big shield button on Home</a:t>
+              <a:t>More languages for the region</a:t>
             </a:r>
           </a:p>
         </p:txBody>
@@ -9921,146 +9921,6 @@
                 <a:cs typeface="Google Sans Flex"/>
                 <a:sym typeface="Google Sans Flex"/>
               </a:rPr>
-              <a:t>More languages for the region</a:t>
-            </a:r>
-          </a:p>
-        </p:txBody>
-      </p:sp>
-      <p:sp>
-        <p:nvSpPr>
-          <p:cNvPr id="169" name="Rounded Rectangle 168"/>
-          <p:cNvSpPr/>
-          <p:nvPr/>
-        </p:nvSpPr>
-        <p:spPr>
-          <a:xfrm>
-            <a:off x="338328" y="3968496"/>
-            <a:ext cx="4069080" cy="512064"/>
-          </a:xfrm>
-          <a:prstGeom prst="roundRect">
-            <a:avLst>
-              <a:gd name="adj" fmla="val 14285"/>
-            </a:avLst>
-          </a:prstGeom>
-          <a:solidFill>
-            <a:srgbClr val="F7F3EE"/>
-          </a:solidFill>
-          <a:ln w="9525">
-            <a:solidFill>
-              <a:srgbClr val="E6DED3"/>
-            </a:solidFill>
-          </a:ln>
-          <a:effectLst/>
-        </p:spPr>
-        <p:txBody>
-          <a:bodyPr rtlCol="0" anchor="ctr"/>
-          <a:lstStyle/>
-          <a:p/>
-        </p:txBody>
-      </p:sp>
-      <p:sp>
-        <p:nvSpPr>
-          <p:cNvPr id="170" name="Oval 169"/>
-          <p:cNvSpPr/>
-          <p:nvPr/>
-        </p:nvSpPr>
-        <p:spPr>
-          <a:xfrm>
-            <a:off x="448056" y="4069080"/>
-            <a:ext cx="310896" cy="310896"/>
-          </a:xfrm>
-          <a:prstGeom prst="ellipse">
-            <a:avLst/>
-          </a:prstGeom>
-          <a:solidFill>
-            <a:srgbClr val="1F1A17"/>
-          </a:solidFill>
-          <a:ln>
-            <a:noFill/>
-          </a:ln>
-          <a:effectLst/>
-        </p:spPr>
-        <p:txBody>
-          <a:bodyPr rtlCol="0" anchor="ctr"/>
-          <a:lstStyle/>
-          <a:p/>
-        </p:txBody>
-      </p:sp>
-      <p:sp>
-        <p:nvSpPr>
-          <p:cNvPr id="171" name="TextBox 170"/>
-          <p:cNvSpPr txBox="1"/>
-          <p:nvPr/>
-        </p:nvSpPr>
-        <p:spPr>
-          <a:xfrm>
-            <a:off x="448056" y="4069080"/>
-            <a:ext cx="310896" cy="310896"/>
-          </a:xfrm>
-          <a:prstGeom prst="rect">
-            <a:avLst/>
-          </a:prstGeom>
-          <a:noFill/>
-        </p:spPr>
-        <p:txBody>
-          <a:bodyPr wrap="square" anchor="ctr" lIns="0" rIns="0" tIns="0" bIns="0"/>
-          <a:lstStyle/>
-          <a:p>
-            <a:pPr algn="ctr">
-              <a:lnSpc>
-                <a:spcPct val="110000"/>
-              </a:lnSpc>
-            </a:pPr>
-            <a:r>
-              <a:rPr sz="1000" b="1">
-                <a:solidFill>
-                  <a:srgbClr val="FFFFFF"/>
-                </a:solidFill>
-                <a:latin typeface="Google Sans Flex"/>
-                <a:ea typeface="Google Sans Flex"/>
-                <a:cs typeface="Google Sans Flex"/>
-                <a:sym typeface="Google Sans Flex"/>
-              </a:rPr>
-              <a:t>5</a:t>
-            </a:r>
-          </a:p>
-        </p:txBody>
-      </p:sp>
-      <p:sp>
-        <p:nvSpPr>
-          <p:cNvPr id="172" name="TextBox 171"/>
-          <p:cNvSpPr txBox="1"/>
-          <p:nvPr/>
-        </p:nvSpPr>
-        <p:spPr>
-          <a:xfrm>
-            <a:off x="886968" y="4005072"/>
-            <a:ext cx="3429000" cy="438912"/>
-          </a:xfrm>
-          <a:prstGeom prst="rect">
-            <a:avLst/>
-          </a:prstGeom>
-          <a:noFill/>
-        </p:spPr>
-        <p:txBody>
-          <a:bodyPr wrap="square" anchor="ctr" lIns="0" rIns="0" tIns="0" bIns="0"/>
-          <a:lstStyle/>
-          <a:p>
-            <a:pPr algn="l">
-              <a:lnSpc>
-                <a:spcPct val="110000"/>
-              </a:lnSpc>
-            </a:pPr>
-            <a:r>
-              <a:rPr sz="1150" b="1">
-                <a:solidFill>
-                  <a:srgbClr val="1F1A17"/>
-                </a:solidFill>
-                <a:latin typeface="Google Sans Flex"/>
-                <a:ea typeface="Google Sans Flex"/>
-                <a:cs typeface="Google Sans Flex"/>
-                <a:sym typeface="Google Sans Flex"/>
-              </a:rPr>
               <a:t>Pilots with migrant worker NGOs</a:t>
             </a:r>
           </a:p>
@@ -10068,7 +9928,7 @@
       </p:sp>
       <p:sp>
         <p:nvSpPr>
-          <p:cNvPr id="173" name="TextBox 172"/>
+          <p:cNvPr id="169" name="TextBox 168"/>
           <p:cNvSpPr txBox="1"/>
           <p:nvPr/>
         </p:nvSpPr>
@@ -10108,18 +9968,18 @@
       </p:sp>
       <p:sp>
         <p:nvSpPr>
-          <p:cNvPr id="174" name="Rounded Rectangle 173"/>
+          <p:cNvPr id="170" name="Rounded Rectangle 169"/>
           <p:cNvSpPr/>
           <p:nvPr/>
         </p:nvSpPr>
         <p:spPr>
           <a:xfrm>
             <a:off x="4681728" y="1481328"/>
-            <a:ext cx="4114800" cy="2999232"/>
+            <a:ext cx="4114800" cy="2377440"/>
           </a:xfrm>
           <a:prstGeom prst="roundRect">
             <a:avLst>
-              <a:gd name="adj" fmla="val 2439"/>
+              <a:gd name="adj" fmla="val 3076"/>
             </a:avLst>
           </a:prstGeom>
           <a:solidFill>
@@ -10140,14 +10000,14 @@
       </p:sp>
       <p:sp>
         <p:nvSpPr>
-          <p:cNvPr id="175" name="TextBox 174"/>
+          <p:cNvPr id="171" name="TextBox 170"/>
           <p:cNvSpPr txBox="1"/>
           <p:nvPr/>
         </p:nvSpPr>
         <p:spPr>
           <a:xfrm>
             <a:off x="4846320" y="1600200"/>
-            <a:ext cx="3794760" cy="2788920"/>
+            <a:ext cx="3794760" cy="2194560"/>
           </a:xfrm>
           <a:prstGeom prst="rect">
             <a:avLst/>
@@ -10196,28 +10056,6 @@
                 <a:sym typeface="Google Sans Flex"/>
               </a:rPr>
               <a:t>•  Real-screenshot labels are drafts from two models, so that score is provisional.</a:t>
-            </a:r>
-          </a:p>
-          <a:p>
-            <a:pPr algn="l">
-              <a:lnSpc>
-                <a:spcPct val="115000"/>
-              </a:lnSpc>
-              <a:spcBef>
-                <a:spcPts val="1000"/>
-              </a:spcBef>
-            </a:pPr>
-            <a:r>
-              <a:rPr sz="1150" b="0">
-                <a:solidFill>
-                  <a:srgbClr val="57504A"/>
-                </a:solidFill>
-                <a:latin typeface="Google Sans Flex"/>
-                <a:ea typeface="Google Sans Flex"/>
-                <a:cs typeface="Google Sans Flex"/>
-                <a:sym typeface="Google Sans Flex"/>
-              </a:rPr>
-              <a:t>•  The API runs on our host behind a Cloudflare tunnel until Cloud Run billing is on.</a:t>
             </a:r>
           </a:p>
           <a:p>
@@ -10558,7 +10396,6 @@
                 <a:ea typeface="Google Sans Flex Medium"/>
                 <a:cs typeface="Google Sans Flex Medium"/>
                 <a:sym typeface="Google Sans Flex Medium"/>
-                <a:hlinkClick r:id="rId6"/>
               </a:rPr>
               <a:t>, Android APK </a:t>
             </a:r>
@@ -10570,7 +10407,7 @@
                 <a:sym typeface="Google Sans Flex Medium"/>
                 <a:hlinkClick r:id="rId7"/>
               </a:rPr>
-              <a:t>https://saferoute-api.akkhayar.com/download</a:t>
+              <a:t>https://saferoute-aibc.web.app/saferoute.apk</a:t>
             </a:r>
             <a:endParaRPr>
               <a:latin typeface="Google Sans Flex Medium"/>
@@ -11560,7 +11397,7 @@
       </p:sp>
       <p:pic>
         <p:nvPicPr>
-          <p:cNvPr id="180" name="Picture 179" descr="ph-privacy.png"/>
+          <p:cNvPr id="180" name="Picture 179" descr="ph-settings.png"/>
           <p:cNvPicPr>
             <a:picLocks noChangeAspect="1"/>
           </p:cNvPicPr>
@@ -11957,7 +11794,7 @@
                 <a:cs typeface="Google Sans Flex"/>
                 <a:sym typeface="Google Sans Flex"/>
               </a:rPr>
-              <a:t>Formerly SafeRoute. The app build, package and links still use that name.</a:t>
+              <a:t>The package name and web addresses keep the earlier project name saferoute.</a:t>
             </a:r>
           </a:p>
         </p:txBody>
@@ -15058,8 +14895,8 @@
         </p:blipFill>
         <p:spPr>
           <a:xfrm>
-            <a:off x="1259609" y="1115568"/>
-            <a:ext cx="1672766" cy="3154680"/>
+            <a:off x="461495" y="1115568"/>
+            <a:ext cx="1822704" cy="3154680"/>
           </a:xfrm>
           <a:prstGeom prst="rect">
             <a:avLst/>
@@ -15079,8 +14916,8 @@
         </p:nvSpPr>
         <p:spPr>
           <a:xfrm>
-            <a:off x="1168169" y="4325112"/>
-            <a:ext cx="1855646" cy="274320"/>
+            <a:off x="370055" y="4325112"/>
+            <a:ext cx="2005584" cy="274320"/>
           </a:xfrm>
           <a:prstGeom prst="rect">
             <a:avLst/>
@@ -15127,8 +14964,8 @@
         </p:blipFill>
         <p:spPr>
           <a:xfrm>
-            <a:off x="3252415" y="1115568"/>
-            <a:ext cx="1676508" cy="3154680"/>
+            <a:off x="2604239" y="1115568"/>
+            <a:ext cx="1822704" cy="3154680"/>
           </a:xfrm>
           <a:prstGeom prst="rect">
             <a:avLst/>
@@ -15148,8 +14985,8 @@
         </p:nvSpPr>
         <p:spPr>
           <a:xfrm>
-            <a:off x="3160975" y="4325112"/>
-            <a:ext cx="1859388" cy="274320"/>
+            <a:off x="2512799" y="4325112"/>
+            <a:ext cx="2005584" cy="274320"/>
           </a:xfrm>
           <a:prstGeom prst="rect">
             <a:avLst/>
@@ -15182,7 +15019,7 @@
       </p:sp>
       <p:pic>
         <p:nvPicPr>
-          <p:cNvPr id="108" name="Picture 107" descr="mock-check-empty.png"/>
+          <p:cNvPr id="108" name="Picture 107" descr="mock-check-message.png"/>
           <p:cNvPicPr>
             <a:picLocks noChangeAspect="1"/>
           </p:cNvPicPr>
@@ -15196,8 +15033,8 @@
         </p:blipFill>
         <p:spPr>
           <a:xfrm>
-            <a:off x="5248964" y="1115568"/>
-            <a:ext cx="1156360" cy="3154680"/>
+            <a:off x="4746983" y="1115568"/>
+            <a:ext cx="1864129" cy="3154680"/>
           </a:xfrm>
           <a:prstGeom prst="rect">
             <a:avLst/>
@@ -15217,8 +15054,8 @@
         </p:nvSpPr>
         <p:spPr>
           <a:xfrm>
-            <a:off x="5157524" y="4325112"/>
-            <a:ext cx="1339240" cy="274320"/>
+            <a:off x="4655543" y="4325112"/>
+            <a:ext cx="2047009" cy="274320"/>
           </a:xfrm>
           <a:prstGeom prst="rect">
             <a:avLst/>
@@ -15244,14 +15081,14 @@
                 <a:cs typeface="Google Sans Flex"/>
                 <a:sym typeface="Google Sans Flex"/>
               </a:rPr>
-              <a:t>Job offer, empty</a:t>
+              <a:t>Check, message</a:t>
             </a:r>
           </a:p>
         </p:txBody>
       </p:sp>
       <p:pic>
         <p:nvPicPr>
-          <p:cNvPr id="110" name="Picture 109" descr="mock-check-filled.png"/>
+          <p:cNvPr id="110" name="Picture 109" descr="mock-check-job.png"/>
           <p:cNvPicPr>
             <a:picLocks noChangeAspect="1"/>
           </p:cNvPicPr>
@@ -15265,8 +15102,8 @@
         </p:blipFill>
         <p:spPr>
           <a:xfrm>
-            <a:off x="6725365" y="1115568"/>
-            <a:ext cx="1159025" cy="3154680"/>
+            <a:off x="6931152" y="1115568"/>
+            <a:ext cx="1751352" cy="3154680"/>
           </a:xfrm>
           <a:prstGeom prst="rect">
             <a:avLst/>
@@ -15286,8 +15123,8 @@
         </p:nvSpPr>
         <p:spPr>
           <a:xfrm>
-            <a:off x="6633925" y="4325112"/>
-            <a:ext cx="1341905" cy="274320"/>
+            <a:off x="6839712" y="4325112"/>
+            <a:ext cx="1934232" cy="274320"/>
           </a:xfrm>
           <a:prstGeom prst="rect">
             <a:avLst/>
@@ -15313,7 +15150,7 @@
                 <a:cs typeface="Google Sans Flex"/>
                 <a:sym typeface="Google Sans Flex"/>
               </a:rPr>
-              <a:t>Job offer, filled</a:t>
+              <a:t>Check, job offer filled</a:t>
             </a:r>
           </a:p>
         </p:txBody>
@@ -15353,7 +15190,7 @@
                 <a:cs typeface="Google Sans Flex"/>
                 <a:sym typeface="Google Sans Flex"/>
               </a:rPr>
-              <a:t>Approved design mockups for the next Home (one big shield button) and Check page, in English. The logo row is cropped.</a:t>
+              <a:t>Approved design mockups for Home (one big shield button) and the Check v3 page with kind chips, in English. The logo row and the footer line are cropped.</a:t>
             </a:r>
           </a:p>
         </p:txBody>
@@ -15565,12 +15402,12 @@
         </p:nvSpPr>
         <p:spPr>
           <a:xfrm>
-            <a:off x="338328" y="3950208"/>
-            <a:ext cx="4160520" cy="841248"/>
+            <a:off x="338328" y="4023360"/>
+            <a:ext cx="8467344" cy="731520"/>
           </a:xfrm>
           <a:prstGeom prst="roundRect">
             <a:avLst>
-              <a:gd name="adj" fmla="val 8695"/>
+              <a:gd name="adj" fmla="val 10000"/>
             </a:avLst>
           </a:prstGeom>
           <a:solidFill>
@@ -15597,8 +15434,8 @@
         </p:nvSpPr>
         <p:spPr>
           <a:xfrm>
-            <a:off x="475488" y="4023360"/>
-            <a:ext cx="3931920" cy="731520"/>
+            <a:off x="502920" y="4114800"/>
+            <a:ext cx="8138160" cy="594360"/>
           </a:xfrm>
           <a:prstGeom prst="rect">
             <a:avLst/>
@@ -15624,7 +15461,7 @@
                 <a:cs typeface="Google Sans Flex"/>
                 <a:sym typeface="Google Sans Flex"/>
               </a:rPr>
-              <a:t>Firebase</a:t>
+              <a:t>Hosting</a:t>
             </a:r>
           </a:p>
           <a:p>
@@ -15637,7 +15474,7 @@
               </a:spcBef>
             </a:pPr>
             <a:r>
-              <a:rPr sz="1050" b="0">
+              <a:rPr sz="1100" b="0">
                 <a:solidFill>
                   <a:srgbClr val="57504A"/>
                 </a:solidFill>
@@ -15646,101 +15483,7 @@
                 <a:cs typeface="Google Sans Flex"/>
                 <a:sym typeface="Google Sans Flex"/>
               </a:rPr>
-              <a:t>Auth, Firestore, Hosting for the web demo, App Distribution for test builds.</a:t>
-            </a:r>
-          </a:p>
-        </p:txBody>
-      </p:sp>
-      <p:sp>
-        <p:nvSpPr>
-          <p:cNvPr id="115" name="Rounded Rectangle 114"/>
-          <p:cNvSpPr/>
-          <p:nvPr/>
-        </p:nvSpPr>
-        <p:spPr>
-          <a:xfrm>
-            <a:off x="4645152" y="3950208"/>
-            <a:ext cx="4160520" cy="841248"/>
-          </a:xfrm>
-          <a:prstGeom prst="roundRect">
-            <a:avLst>
-              <a:gd name="adj" fmla="val 8695"/>
-            </a:avLst>
-          </a:prstGeom>
-          <a:solidFill>
-            <a:srgbClr val="F7F3EE"/>
-          </a:solidFill>
-          <a:ln w="9525">
-            <a:solidFill>
-              <a:srgbClr val="E6DED3"/>
-            </a:solidFill>
-          </a:ln>
-          <a:effectLst/>
-        </p:spPr>
-        <p:txBody>
-          <a:bodyPr rtlCol="0" anchor="ctr"/>
-          <a:lstStyle/>
-          <a:p/>
-        </p:txBody>
-      </p:sp>
-      <p:sp>
-        <p:nvSpPr>
-          <p:cNvPr id="116" name="TextBox 115"/>
-          <p:cNvSpPr txBox="1"/>
-          <p:nvPr/>
-        </p:nvSpPr>
-        <p:spPr>
-          <a:xfrm>
-            <a:off x="4782312" y="4023360"/>
-            <a:ext cx="3931920" cy="731520"/>
-          </a:xfrm>
-          <a:prstGeom prst="rect">
-            <a:avLst/>
-          </a:prstGeom>
-          <a:noFill/>
-        </p:spPr>
-        <p:txBody>
-          <a:bodyPr wrap="square" anchor="t" lIns="0" rIns="0" tIns="0" bIns="0"/>
-          <a:lstStyle/>
-          <a:p>
-            <a:pPr algn="l">
-              <a:lnSpc>
-                <a:spcPct val="110000"/>
-              </a:lnSpc>
-            </a:pPr>
-            <a:r>
-              <a:rPr sz="1100" b="1">
-                <a:solidFill>
-                  <a:srgbClr val="1F1A17"/>
-                </a:solidFill>
-                <a:latin typeface="Google Sans Flex"/>
-                <a:ea typeface="Google Sans Flex"/>
-                <a:cs typeface="Google Sans Flex"/>
-                <a:sym typeface="Google Sans Flex"/>
-              </a:rPr>
-              <a:t>API hosting today</a:t>
-            </a:r>
-          </a:p>
-          <a:p>
-            <a:pPr algn="l">
-              <a:lnSpc>
-                <a:spcPct val="110000"/>
-              </a:lnSpc>
-              <a:spcBef>
-                <a:spcPts val="200"/>
-              </a:spcBef>
-            </a:pPr>
-            <a:r>
-              <a:rPr sz="1050" b="0">
-                <a:solidFill>
-                  <a:srgbClr val="57504A"/>
-                </a:solidFill>
-                <a:latin typeface="Google Sans Flex"/>
-                <a:ea typeface="Google Sans Flex"/>
-                <a:cs typeface="Google Sans Flex"/>
-                <a:sym typeface="Google Sans Flex"/>
-              </a:rPr>
-              <a:t>A Hono service on our host behind a Cloudflare tunnel. The Cloud Run deploy script is ready and needs a billing account.</a:t>
+              <a:t>API on Cloud Run (asia-southeast1, Singapore). Firebase for sign-in, data, web hosting and test builds.</a:t>
             </a:r>
           </a:p>
         </p:txBody>
@@ -15930,7 +15673,7 @@
         </p:nvGraphicFramePr>
         <p:xfrm>
           <a:off x="338328" y="1097280"/>
-          <a:ext cx="8467344" cy="3319272"/>
+          <a:ext cx="8467344" cy="3621024"/>
         </p:xfrm>
         <a:graphic>
           <a:graphicData uri="http://schemas.openxmlformats.org/drawingml/2006/table">
@@ -16374,7 +16117,7 @@
                           <a:cs typeface="Google Sans Flex"/>
                           <a:sym typeface="Google Sans Flex"/>
                         </a:rPr>
-                        <a:t>Expo 52, React Native 0.76, TypeScript</a:t>
+                        <a:t>Cloud Run, asia-southeast1</a:t>
                       </a:r>
                     </a:p>
                   </a:txBody>
@@ -16399,7 +16142,7 @@
                           <a:cs typeface="Google Sans Flex"/>
                           <a:sym typeface="Google Sans Flex"/>
                         </a:rPr>
-                        <a:t>The Android app and the web demo</a:t>
+                        <a:t>Hosts the check API and the voice relay</a:t>
                       </a:r>
                     </a:p>
                   </a:txBody>
@@ -16426,7 +16169,7 @@
                           <a:cs typeface="Google Sans Flex"/>
                           <a:sym typeface="Google Sans Flex"/>
                         </a:rPr>
-                        <a:t>Hono on Node 22, TypeScript</a:t>
+                        <a:t>Expo 52, React Native 0.76, TypeScript</a:t>
                       </a:r>
                     </a:p>
                   </a:txBody>
@@ -16451,7 +16194,7 @@
                           <a:cs typeface="Google Sans Flex"/>
                           <a:sym typeface="Google Sans Flex"/>
                         </a:rPr>
-                        <a:t>The check API, the rules engine and the voice relay</a:t>
+                        <a:t>The Android app and the web demo</a:t>
                       </a:r>
                     </a:p>
                   </a:txBody>
@@ -16478,7 +16221,7 @@
                           <a:cs typeface="Google Sans Flex"/>
                           <a:sym typeface="Google Sans Flex"/>
                         </a:rPr>
-                        <a:t>Kotlin Android module</a:t>
+                        <a:t>Hono on Node 22, TypeScript</a:t>
                       </a:r>
                     </a:p>
                   </a:txBody>
@@ -16503,13 +16246,65 @@
                           <a:cs typeface="Google Sans Flex"/>
                           <a:sym typeface="Google Sans Flex"/>
                         </a:rPr>
+                        <a:t>The check API, the rules engine and the voice relay</a:t>
+                      </a:r>
+                    </a:p>
+                  </a:txBody>
+                  <a:tcPr marL="91440" marR="91440" marT="27432" marB="27432" anchor="ctr">
+                    <a:solidFill>
+                      <a:srgbClr val="FFFFFF"/>
+                    </a:solidFill>
+                  </a:tcPr>
+                </a:tc>
+              </a:tr>
+              <a:tr h="301752">
+                <a:tc>
+                  <a:txBody>
+                    <a:bodyPr/>
+                    <a:lstStyle/>
+                    <a:p>
+                      <a:r>
+                        <a:rPr sz="1050" b="1">
+                          <a:solidFill>
+                            <a:srgbClr val="1F1A17"/>
+                          </a:solidFill>
+                          <a:latin typeface="Google Sans Flex"/>
+                          <a:ea typeface="Google Sans Flex"/>
+                          <a:cs typeface="Google Sans Flex"/>
+                          <a:sym typeface="Google Sans Flex"/>
+                        </a:rPr>
+                        <a:t>Kotlin Android module</a:t>
+                      </a:r>
+                    </a:p>
+                  </a:txBody>
+                  <a:tcPr marL="91440" marR="91440" marT="27432" marB="27432" anchor="ctr">
+                    <a:solidFill>
+                      <a:srgbClr val="F7F3EE"/>
+                    </a:solidFill>
+                  </a:tcPr>
+                </a:tc>
+                <a:tc>
+                  <a:txBody>
+                    <a:bodyPr/>
+                    <a:lstStyle/>
+                    <a:p>
+                      <a:r>
+                        <a:rPr sz="1050" b="0">
+                          <a:solidFill>
+                            <a:srgbClr val="57504A"/>
+                          </a:solidFill>
+                          <a:latin typeface="Google Sans Flex"/>
+                          <a:ea typeface="Google Sans Flex"/>
+                          <a:cs typeface="Google Sans Flex"/>
+                          <a:sym typeface="Google Sans Flex"/>
+                        </a:rPr>
                         <a:t>The screen bubble and Message Guard</a:t>
                       </a:r>
                     </a:p>
                   </a:txBody>
                   <a:tcPr marL="91440" marR="91440" marT="27432" marB="27432" anchor="ctr">
                     <a:solidFill>
-                      <a:srgbClr val="FFFFFF"/>
+                      <a:srgbClr val="F7F3EE"/>
                     </a:solidFill>
                   </a:tcPr>
                 </a:tc>

</xml_diff>

<commit_message>
docs: final deck with team details, fresh Kakwe screens and no Message Guard
Team Super Power Rangers on slide 1 and the links slide. Message Guard is
gone from the features, safety, technologies and limits; the features grid
gains Scam radar and the safety slide lists the on-demand permissions.
Home, Check, High risk report and Job Shield screens are retaken from the
release commit against the Cloud Run API by scripts/e2e-deck.mjs.
</commit_message>
<xml_diff>
--- a/pitch/Kakwe-AIBuilderCup-submission.pptx
+++ b/pitch/Kakwe-AIBuilderCup-submission.pptx
@@ -6876,7 +6876,7 @@
         </p:nvSpPr>
         <p:spPr>
           <a:xfrm>
-            <a:off x="146600" y="2902694"/>
+            <a:off x="146600" y="2743200"/>
             <a:ext cx="7315200" cy="2003700"/>
           </a:xfrm>
           <a:prstGeom prst="rect">
@@ -6919,26 +6919,6 @@
             </a:endParaRPr>
           </a:p>
           <a:p>
-            <a:pPr indent="0" lvl="0" marL="0" rtl="0" algn="l">
-              <a:spcBef>
-                <a:spcPts val="0"/>
-              </a:spcBef>
-              <a:spcAft>
-                <a:spcPts val="0"/>
-              </a:spcAft>
-              <a:buNone/>
-            </a:pPr>
-            <a:r>
-              <a:t/>
-            </a:r>
-            <a:endParaRPr sz="1800">
-              <a:latin typeface="Google Sans Flex Medium"/>
-              <a:ea typeface="Google Sans Flex Medium"/>
-              <a:cs typeface="Google Sans Flex Medium"/>
-              <a:sym typeface="Google Sans Flex Medium"/>
-            </a:endParaRPr>
-          </a:p>
-          <a:p>
             <a:pPr indent="-342900" lvl="1" marL="914400" rtl="0" algn="l">
               <a:spcBef>
                 <a:spcPts val="0"/>
@@ -6960,31 +6940,13 @@
               <a:t>Team name: </a:t>
             </a:r>
             <a:r>
-              <a:rPr lang="en-GB" sz="1800" b="0">
+              <a:rPr lang="en-GB" sz="1800">
                 <a:latin typeface="Google Sans Flex"/>
                 <a:ea typeface="Google Sans Flex"/>
                 <a:cs typeface="Google Sans Flex"/>
                 <a:sym typeface="Google Sans Flex"/>
               </a:rPr>
-              <a:t>Kakwe (</a:t>
-            </a:r>
-            <a:r>
-              <a:rPr lang="en-GB" sz="1800" b="0">
-                <a:latin typeface="A10_YoeShin"/>
-                <a:ea typeface="A10_YoeShin"/>
-                <a:cs typeface="A10_YoeShin"/>
-                <a:sym typeface="A10_YoeShin"/>
-              </a:rPr>
-              <a:t>ကာကွယ်</a:t>
-            </a:r>
-            <a:r>
-              <a:rPr lang="en-GB" sz="1800" b="0">
-                <a:latin typeface="Google Sans Flex"/>
-                <a:ea typeface="Google Sans Flex"/>
-                <a:cs typeface="Google Sans Flex"/>
-                <a:sym typeface="Google Sans Flex"/>
-              </a:rPr>
-              <a:t>)</a:t>
+              <a:t>Super Power Rangers</a:t>
             </a:r>
             <a:endParaRPr sz="1800">
               <a:latin typeface="Google Sans Flex"/>
@@ -7021,7 +6983,16 @@
                 <a:cs typeface="Google Sans Flex"/>
                 <a:sym typeface="Google Sans Flex"/>
               </a:rPr>
-              <a:t>Ricky</a:t>
+              <a:t>Pyae Sone Myo (Ricky)</a:t>
+            </a:r>
+            <a:r>
+              <a:rPr lang="en-GB" sz="1200">
+                <a:latin typeface="Google Sans Flex"/>
+                <a:ea typeface="Google Sans Flex"/>
+                <a:cs typeface="Google Sans Flex"/>
+                <a:sym typeface="Google Sans Flex"/>
+              </a:rPr>
+              <a:t>   Members: Min Thein Kyaw, May Myat Noe Aung</a:t>
             </a:r>
             <a:endParaRPr sz="1800">
               <a:latin typeface="Google Sans Flex"/>
@@ -7052,13 +7023,13 @@
               <a:t>Problem Statement: </a:t>
             </a:r>
             <a:r>
-              <a:rPr lang="en-GB" sz="1250">
+              <a:rPr lang="en-GB" sz="1200">
                 <a:latin typeface="Google Sans Flex"/>
                 <a:ea typeface="Google Sans Flex"/>
                 <a:cs typeface="Google Sans Flex"/>
                 <a:sym typeface="Google Sans Flex"/>
               </a:rPr>
-              <a:t>Recruitment ads on Facebook, Viber and Telegram lure young job seekers from Myanmar and the region into forced online scam work; OHCHR says at least 120,000 people in Myanmar may be held in it. They need to see the warning signs, in their own language, before they pay, send documents or travel.</a:t>
+              <a:t>Recruitment ads on Facebook, Viber and Telegram lure young job seekers from Myanmar and the region into forced online scam work; OHCHR says at least 120,000 people in Myanmar may be held in it. Kakwe helps them see the warning signs, in their own language, before they pay, send documents or travel.</a:t>
             </a:r>
             <a:endParaRPr sz="1800">
               <a:latin typeface="Google Sans Flex"/>
@@ -7884,7 +7855,7 @@
       </p:sp>
       <p:pic>
         <p:nvPicPr>
-          <p:cNvPr id="136" name="Picture 135" descr="ph-check.png"/>
+          <p:cNvPr id="136" name="Picture 135" descr="ph-home.png"/>
           <p:cNvPicPr>
             <a:picLocks noChangeAspect="1"/>
           </p:cNvPicPr>
@@ -7915,6 +7886,70 @@
         <p:spPr>
           <a:xfrm>
             <a:off x="201168" y="4151376"/>
+            <a:ext cx="1766316" cy="384048"/>
+          </a:xfrm>
+          <a:prstGeom prst="rect">
+            <a:avLst/>
+          </a:prstGeom>
+          <a:noFill/>
+        </p:spPr>
+        <p:txBody>
+          <a:bodyPr wrap="square" anchor="t" lIns="0" rIns="0" tIns="0" bIns="0"/>
+          <a:lstStyle/>
+          <a:p>
+            <a:pPr algn="ctr">
+              <a:lnSpc>
+                <a:spcPct val="110000"/>
+              </a:lnSpc>
+            </a:pPr>
+            <a:r>
+              <a:rPr sz="1000" b="1">
+                <a:solidFill>
+                  <a:srgbClr val="1F1A17"/>
+                </a:solidFill>
+                <a:latin typeface="Google Sans Flex"/>
+                <a:ea typeface="Google Sans Flex"/>
+                <a:cs typeface="Google Sans Flex"/>
+                <a:sym typeface="Google Sans Flex"/>
+              </a:rPr>
+              <a:t>Home: the shield circle</a:t>
+            </a:r>
+          </a:p>
+        </p:txBody>
+      </p:sp>
+      <p:pic>
+        <p:nvPicPr>
+          <p:cNvPr id="138" name="Picture 137" descr="ph-check.png"/>
+          <p:cNvPicPr>
+            <a:picLocks noChangeAspect="1"/>
+          </p:cNvPicPr>
+          <p:nvPr/>
+        </p:nvPicPr>
+        <p:blipFill>
+          <a:blip r:embed="rId6"/>
+          <a:stretch>
+            <a:fillRect/>
+          </a:stretch>
+        </p:blipFill>
+        <p:spPr>
+          <a:xfrm>
+            <a:off x="2082164" y="1078992"/>
+            <a:ext cx="1491996" cy="3017520"/>
+          </a:xfrm>
+          <a:prstGeom prst="rect">
+            <a:avLst/>
+          </a:prstGeom>
+        </p:spPr>
+      </p:pic>
+      <p:sp>
+        <p:nvSpPr>
+          <p:cNvPr id="139" name="TextBox 138"/>
+          <p:cNvSpPr txBox="1"/>
+          <p:nvPr/>
+        </p:nvSpPr>
+        <p:spPr>
+          <a:xfrm>
+            <a:off x="1945005" y="4151376"/>
             <a:ext cx="1766316" cy="384048"/>
           </a:xfrm>
           <a:prstGeom prst="rect">
@@ -7948,21 +7983,21 @@
       </p:sp>
       <p:pic>
         <p:nvPicPr>
-          <p:cNvPr id="138" name="Picture 137" descr="ph-danger-en.png"/>
+          <p:cNvPr id="140" name="Picture 139" descr="ph-danger-en.png"/>
           <p:cNvPicPr>
             <a:picLocks noChangeAspect="1"/>
           </p:cNvPicPr>
           <p:nvPr/>
         </p:nvPicPr>
         <p:blipFill>
-          <a:blip r:embed="rId6"/>
+          <a:blip r:embed="rId7"/>
           <a:stretch>
             <a:fillRect/>
           </a:stretch>
         </p:blipFill>
         <p:spPr>
           <a:xfrm>
-            <a:off x="2082164" y="1078992"/>
+            <a:off x="3826001" y="1078992"/>
             <a:ext cx="1491996" cy="3017520"/>
           </a:xfrm>
           <a:prstGeom prst="rect">
@@ -7972,13 +8007,13 @@
       </p:pic>
       <p:sp>
         <p:nvSpPr>
-          <p:cNvPr id="139" name="TextBox 138"/>
+          <p:cNvPr id="141" name="TextBox 140"/>
           <p:cNvSpPr txBox="1"/>
           <p:nvPr/>
         </p:nvSpPr>
         <p:spPr>
           <a:xfrm>
-            <a:off x="1945005" y="4151376"/>
+            <a:off x="3688841" y="4151376"/>
             <a:ext cx="1766316" cy="384048"/>
           </a:xfrm>
           <a:prstGeom prst="rect">
@@ -8012,21 +8047,21 @@
       </p:sp>
       <p:pic>
         <p:nvPicPr>
-          <p:cNvPr id="140" name="Picture 139" descr="ph-jobshield.png"/>
+          <p:cNvPr id="142" name="Picture 141" descr="ph-jobshield.png"/>
           <p:cNvPicPr>
             <a:picLocks noChangeAspect="1"/>
           </p:cNvPicPr>
           <p:nvPr/>
         </p:nvPicPr>
         <p:blipFill>
-          <a:blip r:embed="rId7"/>
+          <a:blip r:embed="rId8"/>
           <a:stretch>
             <a:fillRect/>
           </a:stretch>
         </p:blipFill>
         <p:spPr>
           <a:xfrm>
-            <a:off x="3826001" y="1078992"/>
+            <a:off x="5569839" y="1078992"/>
             <a:ext cx="1491996" cy="3017520"/>
           </a:xfrm>
           <a:prstGeom prst="rect">
@@ -8036,13 +8071,13 @@
       </p:pic>
       <p:sp>
         <p:nvSpPr>
-          <p:cNvPr id="141" name="TextBox 140"/>
+          <p:cNvPr id="143" name="TextBox 142"/>
           <p:cNvSpPr txBox="1"/>
           <p:nvPr/>
         </p:nvSpPr>
         <p:spPr>
           <a:xfrm>
-            <a:off x="3688841" y="4151376"/>
+            <a:off x="5432678" y="4151376"/>
             <a:ext cx="1766316" cy="384048"/>
           </a:xfrm>
           <a:prstGeom prst="rect">
@@ -8076,21 +8111,21 @@
       </p:sp>
       <p:pic>
         <p:nvPicPr>
-          <p:cNvPr id="142" name="Picture 141" descr="ph-bubble.png"/>
+          <p:cNvPr id="144" name="Picture 143" descr="ph-bubble.png"/>
           <p:cNvPicPr>
             <a:picLocks noChangeAspect="1"/>
           </p:cNvPicPr>
           <p:nvPr/>
         </p:nvPicPr>
         <p:blipFill>
-          <a:blip r:embed="rId8"/>
+          <a:blip r:embed="rId9"/>
           <a:stretch>
             <a:fillRect/>
           </a:stretch>
         </p:blipFill>
         <p:spPr>
           <a:xfrm>
-            <a:off x="5569839" y="1078992"/>
+            <a:off x="7313676" y="1078992"/>
             <a:ext cx="1491996" cy="3017520"/>
           </a:xfrm>
           <a:prstGeom prst="rect">
@@ -8100,13 +8135,13 @@
       </p:pic>
       <p:sp>
         <p:nvSpPr>
-          <p:cNvPr id="143" name="TextBox 142"/>
+          <p:cNvPr id="145" name="TextBox 144"/>
           <p:cNvSpPr txBox="1"/>
           <p:nvPr/>
         </p:nvSpPr>
         <p:spPr>
           <a:xfrm>
-            <a:off x="5432678" y="4151376"/>
+            <a:off x="7176515" y="4151376"/>
             <a:ext cx="1766316" cy="384048"/>
           </a:xfrm>
           <a:prstGeom prst="rect">
@@ -8138,70 +8173,6 @@
           </a:p>
         </p:txBody>
       </p:sp>
-      <p:pic>
-        <p:nvPicPr>
-          <p:cNvPr id="144" name="Picture 143" descr="ph-report-my.png"/>
-          <p:cNvPicPr>
-            <a:picLocks noChangeAspect="1"/>
-          </p:cNvPicPr>
-          <p:nvPr/>
-        </p:nvPicPr>
-        <p:blipFill>
-          <a:blip r:embed="rId9"/>
-          <a:stretch>
-            <a:fillRect/>
-          </a:stretch>
-        </p:blipFill>
-        <p:spPr>
-          <a:xfrm>
-            <a:off x="7313676" y="1078992"/>
-            <a:ext cx="1491996" cy="3017520"/>
-          </a:xfrm>
-          <a:prstGeom prst="rect">
-            <a:avLst/>
-          </a:prstGeom>
-        </p:spPr>
-      </p:pic>
-      <p:sp>
-        <p:nvSpPr>
-          <p:cNvPr id="145" name="TextBox 144"/>
-          <p:cNvSpPr txBox="1"/>
-          <p:nvPr/>
-        </p:nvSpPr>
-        <p:spPr>
-          <a:xfrm>
-            <a:off x="7176515" y="4151376"/>
-            <a:ext cx="1766316" cy="384048"/>
-          </a:xfrm>
-          <a:prstGeom prst="rect">
-            <a:avLst/>
-          </a:prstGeom>
-          <a:noFill/>
-        </p:spPr>
-        <p:txBody>
-          <a:bodyPr wrap="square" anchor="t" lIns="0" rIns="0" tIns="0" bIns="0"/>
-          <a:lstStyle/>
-          <a:p>
-            <a:pPr algn="ctr">
-              <a:lnSpc>
-                <a:spcPct val="110000"/>
-              </a:lnSpc>
-            </a:pPr>
-            <a:r>
-              <a:rPr sz="1000" b="1">
-                <a:solidFill>
-                  <a:srgbClr val="1F1A17"/>
-                </a:solidFill>
-                <a:latin typeface="Google Sans Flex"/>
-                <a:ea typeface="Google Sans Flex"/>
-                <a:cs typeface="Google Sans Flex"/>
-                <a:sym typeface="Google Sans Flex"/>
-              </a:rPr>
-              <a:t>Burmese report, voice and family</a:t>
-            </a:r>
-          </a:p>
-        </p:txBody>
-      </p:sp>
       <p:sp>
         <p:nvSpPr>
           <p:cNvPr id="146" name="TextBox 145"/>
@@ -8237,7 +8208,7 @@
                 <a:cs typeface="Google Sans Flex"/>
                 <a:sym typeface="Google Sans Flex"/>
               </a:rPr>
-              <a:t>Web build captures with fictional inputs and the built-in demo data. The bubble shows the Android overlay views on a drawn chat.</a:t>
+              <a:t>Web build of the release commit against the live API, with fictional inputs. The bubble shows the Android overlay views on a drawn chat.</a:t>
             </a:r>
           </a:p>
         </p:txBody>
@@ -10077,7 +10048,7 @@
                 <a:cs typeface="Google Sans Flex"/>
                 <a:sym typeface="Google Sans Flex"/>
               </a:rPr>
-              <a:t>•  The web demo has no screen bubble or Message Guard; both need Android.</a:t>
+              <a:t>•  The web demo has no screen bubble; it needs the Android app.</a:t>
             </a:r>
           </a:p>
         </p:txBody>
@@ -10552,7 +10523,7 @@
                 <a:cs typeface="Google Sans Flex"/>
                 <a:sym typeface="Google Sans Flex"/>
               </a:rPr>
-              <a:t>Ricky (team leader), Min Thein Kyaw</a:t>
+              <a:t>Super Power Rangers. Pyae Sone Myo (Ricky), team leader; Min Thein Kyaw; May Myat Noe Aung</a:t>
             </a:r>
           </a:p>
           <a:p>
@@ -11068,7 +11039,7 @@
                 <a:cs typeface="Google Sans Flex"/>
                 <a:sym typeface="Google Sans Flex"/>
               </a:rPr>
-              <a:t>Signal sharing and Message Guard stay off until the user turns them on.</a:t>
+              <a:t>Sharing is off until turned on. Overlay, screen capture, microphone, notifications and contacts are asked only when needed.</a:t>
             </a:r>
           </a:p>
         </p:txBody>
@@ -12828,7 +12799,7 @@
                 <a:cs typeface="Google Sans Flex"/>
                 <a:sym typeface="Google Sans Flex"/>
               </a:rPr>
-              <a:t>Message Guard</a:t>
+              <a:t>Scam radar</a:t>
             </a:r>
           </a:p>
           <a:p>
@@ -12850,7 +12821,7 @@
                 <a:cs typeface="Google Sans Flex"/>
                 <a:sym typeface="Google Sans Flex"/>
               </a:rPr>
-              <a:t>Android, opt-in. Watches the chat apps you choose and flags risky messages.</a:t>
+              <a:t>Shows which scams people are reporting right now, from opt-in anonymous signals.</a:t>
             </a:r>
           </a:p>
         </p:txBody>
@@ -16298,7 +16269,7 @@
                           <a:cs typeface="Google Sans Flex"/>
                           <a:sym typeface="Google Sans Flex"/>
                         </a:rPr>
-                        <a:t>The screen bubble and Message Guard</a:t>
+                        <a:t>The screen bubble overlay</a:t>
                       </a:r>
                     </a:p>
                   </a:txBody>

</xml_diff>

<commit_message>
docs: call the exit button Quick exit in the submission deck
</commit_message>
<xml_diff>
--- a/pitch/Kakwe-AIBuilderCup-submission.pptx
+++ b/pitch/Kakwe-AIBuilderCup-submission.pptx
@@ -11205,7 +11205,7 @@
                 <a:cs typeface="Google Sans Flex"/>
                 <a:sym typeface="Google Sans Flex"/>
               </a:rPr>
-              <a:t>Leave quickly</a:t>
+              <a:t>Quick exit</a:t>
             </a:r>
           </a:p>
           <a:p>
@@ -13197,7 +13197,7 @@
                 <a:cs typeface="Google Sans Flex"/>
                 <a:sym typeface="Google Sans Flex"/>
               </a:rPr>
-              <a:t>English, Burmese, Bahasa Indonesia, Tagalog and Thai. Leave quickly clears the screen.</a:t>
+              <a:t>English, Burmese, Bahasa Indonesia, Tagalog and Thai. Quick exit clears the screen.</a:t>
             </a:r>
           </a:p>
         </p:txBody>

</xml_diff>